<commit_message>
docs(bao_cao): rebuild report and slides with new dashboard screenshots
- Screenshots retaken on the redesigned UI.
- Decision-tree paragraph (6.6) and feature count read from artifacts.
- OLAP and alerts-page descriptions match the new UI; page list updated.
- AI-use declaration and progress log cover the 2026-10-28 session.

Co-Authored-By: Claude Opus 5.5 <noreply@anthropic.com>
</commit_message>
<xml_diff>
--- a/bao_cao/Slide_BTL_INT1422.pptx
+++ b/bao_cao/Slide_BTL_INT1422.pptx
@@ -1610,7 +1610,7 @@
           <a:lstStyle/>
           <a:p>
             <a:r>
-              <a:t>≈30". DEMO trang /canh-bao: hai ma trận nhầm lẫn cạnh nhau, dòng thời gian xác suất cảnh báo tại một trạm (chấm xanh = cảnh báo đúng, vàng = báo nhầm, đỏ = bỏ sót), bảng so sánh theo trạm.</a:t>
+              <a:t>≈30". DEMO trang /canh-bao: hai ma trận nhầm lẫn cạnh nhau, dòng thời gian PM2.5 thực đo tại một trạm kèm những giờ mô hình đã cảnh báo từ 1 giờ trước (xanh = cảnh báo đúng, vàng = báo nhầm, đỏ = bỏ sót), bảng so sánh theo trạm.</a:t>
             </a:r>
           </a:p>
         </p:txBody>
@@ -6616,7 +6616,7 @@
           <a:p>
             <a:pPr algn="l"/>
             <a:r>
-              <a:rPr sz="2800" b="1" i="0">
+              <a:rPr sz="2400" b="1" i="0">
                 <a:solidFill>
                   <a:srgbClr val="EA580C"/>
                 </a:solidFill>
@@ -6732,7 +6732,7 @@
           <a:p>
             <a:pPr algn="l"/>
             <a:r>
-              <a:rPr sz="2800" b="1" i="0">
+              <a:rPr sz="2400" b="1" i="0">
                 <a:solidFill>
                   <a:srgbClr val="1F2A37"/>
                 </a:solidFill>
@@ -6848,7 +6848,7 @@
           <a:p>
             <a:pPr algn="l"/>
             <a:r>
-              <a:rPr sz="2800" b="1" i="0">
+              <a:rPr sz="2400" b="1" i="0">
                 <a:solidFill>
                   <a:srgbClr val="1F2A37"/>
                 </a:solidFill>
@@ -6964,7 +6964,7 @@
           <a:p>
             <a:pPr algn="l"/>
             <a:r>
-              <a:rPr sz="2800" b="1" i="0">
+              <a:rPr sz="2400" b="1" i="0">
                 <a:solidFill>
                   <a:srgbClr val="64748B"/>
                 </a:solidFill>
@@ -7710,7 +7710,7 @@
                 </a:solidFill>
                 <a:latin typeface="Calibri"/>
               </a:rPr>
-              <a:t>Dòng thời gian xác suất theo trạm</a:t>
+              <a:t>Dòng thời gian PM2.5 và cảnh báo theo trạm</a:t>
             </a:r>
           </a:p>
           <a:p>
@@ -12155,8 +12155,8 @@
         </p:blipFill>
         <p:spPr>
           <a:xfrm>
-            <a:off x="548640" y="1280160"/>
-            <a:ext cx="5688300" cy="4937760"/>
+            <a:off x="548640" y="2011680"/>
+            <a:ext cx="6949440" cy="3309257"/>
           </a:xfrm>
           <a:prstGeom prst="rect">
             <a:avLst/>
@@ -12402,7 +12402,7 @@
                 </a:solidFill>
                 <a:latin typeface="Calibri"/>
               </a:rPr>
-              <a:t>bấm một dòng để khoan xuống</a:t>
+              <a:t>bấm tên hàng/cột để khoan xuống</a:t>
             </a:r>
           </a:p>
         </p:txBody>

</xml_diff>